<commit_message>
just a little alignment
</commit_message>
<xml_diff>
--- a/ppt/FE Assignment-1 Template.pptx
+++ b/ppt/FE Assignment-1 Template.pptx
@@ -4003,11 +4003,18 @@
               </a:lnSpc>
             </a:pPr>
             <a:r>
+              <a:rPr lang="en-US" sz="1200" b="1" spc="-10" dirty="0">
+                <a:latin typeface="Times New Roman"/>
+                <a:cs typeface="Times New Roman"/>
+              </a:rPr>
+              <a:t>Example</a:t>
+            </a:r>
+            <a:r>
               <a:rPr sz="1200" b="1" spc="-10" dirty="0">
                 <a:latin typeface="Times New Roman"/>
                 <a:cs typeface="Times New Roman"/>
               </a:rPr>
-              <a:t>Sample:</a:t>
+              <a:t>:</a:t>
             </a:r>
             <a:endParaRPr sz="1200" dirty="0">
               <a:latin typeface="Times New Roman"/>
@@ -4683,7 +4690,7 @@
         <p:spPr>
           <a:xfrm>
             <a:off x="461484" y="6841660"/>
-            <a:ext cx="6341110" cy="2776401"/>
+            <a:ext cx="6341110" cy="3155992"/>
           </a:xfrm>
           <a:prstGeom prst="rect">
             <a:avLst/>
@@ -4821,6 +4828,34 @@
                 <a:cs typeface="Times New Roman"/>
               </a:rPr>
               <a:t>              Contact Details(Organizer)</a:t>
+            </a:r>
+            <a:endParaRPr lang="en-US" sz="1300" b="1" dirty="0">
+              <a:latin typeface="Times New Roman"/>
+              <a:cs typeface="Times New Roman"/>
+            </a:endParaRPr>
+          </a:p>
+          <a:p>
+            <a:pPr marL="679450">
+              <a:lnSpc>
+                <a:spcPct val="100000"/>
+              </a:lnSpc>
+              <a:spcBef>
+                <a:spcPts val="1430"/>
+              </a:spcBef>
+            </a:pPr>
+            <a:r>
+              <a:rPr lang="en-US" sz="1300" b="1" dirty="0">
+                <a:latin typeface="Times New Roman"/>
+                <a:cs typeface="Times New Roman"/>
+              </a:rPr>
+              <a:t>Name : </a:t>
+            </a:r>
+            <a:r>
+              <a:rPr lang="en-US" sz="1300" dirty="0">
+                <a:latin typeface="Times New Roman"/>
+                <a:cs typeface="Times New Roman"/>
+              </a:rPr>
+              <a:t>Hariharan S</a:t>
             </a:r>
             <a:endParaRPr lang="en-US" sz="1300" b="1" dirty="0">
               <a:latin typeface="Times New Roman"/>

</xml_diff>